<commit_message>
EOD 2026-08-12: Sprint task: Add Aditional Features
## Tasks Completed
- ✅ Add Aditional Features (b1ce165d)

## Files Changed
- AI_Analytics_Dashboard_Presentation.pptx
- README.md
- agents/builder_agent.py
- agents/memory_manager.py
- agents/sprint_watcher_agent.py
- frontend/src/components/AgentPipelineTracker.jsx
- scripts/generate_architecture_pptx.py
- tasks.md
- tests/TEST_CASES.xlsx
- frontend/src/components/AddAditionalFeatures.jsx
- tasks/task_39_readme_architecture_sync.md
- tasks/task_40_daily_memory_recall.md
- tasks/task_41_build_authenticity_pipeline_telemetry.md
- tasks/task_42_build_detail_popup_end_to_end.md
- tests/unit/test_addaditionalfeatures.py
- tests/unit/test_build_detail_persistence.py

🤖 Auto-committed by Git Agent at 13:43
</commit_message>
<xml_diff>
--- a/AI_Analytics_Dashboard_Presentation.pptx
+++ b/AI_Analytics_Dashboard_Presentation.pptx
@@ -12,7 +12,6 @@
     <p:sldId id="260" r:id="rId11"/>
     <p:sldId id="261" r:id="rId12"/>
     <p:sldId id="262" r:id="rId13"/>
-    <p:sldId id="263" r:id="rId14"/>
   </p:sldIdLst>
   <p:sldSz cx="12188952" cy="6858000" type="screen4x3"/>
   <p:notesSz cx="6858000" cy="9144000"/>
@@ -3105,50 +3104,7 @@
       <p:grpSpPr/>
       <p:sp>
         <p:nvSpPr>
-          <p:cNvPr id="2" name="Rectangle 1"/>
-          <p:cNvSpPr/>
-          <p:nvPr/>
-        </p:nvSpPr>
-        <p:spPr>
-          <a:xfrm>
-            <a:off x="0" y="2560320"/>
-            <a:ext cx="12188952" cy="54864"/>
-          </a:xfrm>
-          <a:prstGeom prst="rect">
-            <a:avLst/>
-          </a:prstGeom>
-          <a:solidFill>
-            <a:srgbClr val="7C3AED"/>
-          </a:solidFill>
-          <a:ln>
-            <a:noFill/>
-          </a:ln>
-        </p:spPr>
-        <p:style>
-          <a:lnRef idx="1">
-            <a:schemeClr val="accent1"/>
-          </a:lnRef>
-          <a:fillRef idx="3">
-            <a:schemeClr val="accent1"/>
-          </a:fillRef>
-          <a:effectRef idx="2">
-            <a:schemeClr val="accent1"/>
-          </a:effectRef>
-          <a:fontRef idx="minor">
-            <a:schemeClr val="lt1"/>
-          </a:fontRef>
-        </p:style>
-        <p:txBody>
-          <a:bodyPr rtlCol="0" anchor="ctr"/>
-          <a:lstStyle/>
-          <a:p>
-            <a:pPr algn="ctr"/>
-          </a:p>
-        </p:txBody>
-      </p:sp>
-      <p:sp>
-        <p:nvSpPr>
-          <p:cNvPr id="3" name="TextBox 2"/>
+          <p:cNvPr id="2" name="TextBox 1"/>
           <p:cNvSpPr txBox="1"/>
           <p:nvPr/>
         </p:nvSpPr>
@@ -3213,7 +3169,7 @@
       </p:sp>
       <p:sp>
         <p:nvSpPr>
-          <p:cNvPr id="4" name="TextBox 3"/>
+          <p:cNvPr id="3" name="TextBox 2"/>
           <p:cNvSpPr txBox="1"/>
           <p:nvPr/>
         </p:nvSpPr>
@@ -4249,7 +4205,7 @@
               </a:defRPr>
             </a:pPr>
             <a:r>
-              <a:t>System Architecture</a:t>
+              <a:t>FastAPI Backend</a:t>
             </a:r>
           </a:p>
           <a:p>
@@ -4264,7 +4220,7 @@
               </a:defRPr>
             </a:pPr>
             <a:r>
-              <a:t>Layers we built in this application</a:t>
+              <a:t>Python 3.10 · backend/main.py · OpenAPI at /docs</a:t>
             </a:r>
           </a:p>
         </p:txBody>
@@ -4278,7 +4234,7 @@
         <p:spPr>
           <a:xfrm>
             <a:off x="457200" y="1280160"/>
-            <a:ext cx="11064240" cy="749808"/>
+            <a:ext cx="5303520" cy="4572000"/>
           </a:xfrm>
           <a:prstGeom prst="roundRect">
             <a:avLst/>
@@ -4288,7 +4244,7 @@
           </a:solidFill>
           <a:ln w="19050">
             <a:solidFill>
-              <a:srgbClr val="A78BFA"/>
+              <a:srgbClr val="3B82F6"/>
             </a:solidFill>
           </a:ln>
         </p:spPr>
@@ -4323,7 +4279,7 @@
         <p:spPr>
           <a:xfrm>
             <a:off x="594360" y="1389888"/>
-            <a:ext cx="10789920" cy="566928"/>
+            <a:ext cx="5029200" cy="4389120"/>
           </a:xfrm>
           <a:prstGeom prst="rect">
             <a:avLst/>
@@ -4339,12 +4295,12 @@
             <a:pPr>
               <a:defRPr b="1" sz="1400">
                 <a:solidFill>
-                  <a:srgbClr val="A78BFA"/>
-                </a:solidFill>
-              </a:defRPr>
-            </a:pPr>
-            <a:r>
-              <a:t>Presentation</a:t>
+                  <a:srgbClr val="3B82F6"/>
+                </a:solidFill>
+              </a:defRPr>
+            </a:pPr>
+            <a:r>
+              <a:t>Core Routers</a:t>
             </a:r>
           </a:p>
           <a:p>
@@ -4359,7 +4315,112 @@
               </a:defRPr>
             </a:pPr>
             <a:r>
-              <a:t>React + Vite (:5173) — Dashboard, Analytics, Sprint Board, Agent Monitor</a:t>
+              <a:t>/api/data — CSV/Excel upload, DB queries</a:t>
+            </a:r>
+          </a:p>
+          <a:p>
+            <a:pPr>
+              <a:spcBef>
+                <a:spcPts val="400"/>
+              </a:spcBef>
+              <a:defRPr sz="1100">
+                <a:solidFill>
+                  <a:srgbClr val="E2E8F0"/>
+                </a:solidFill>
+              </a:defRPr>
+            </a:pPr>
+            <a:r>
+              <a:t>/api/analytics — AI Copilot (no-date NL search)</a:t>
+            </a:r>
+          </a:p>
+          <a:p>
+            <a:pPr>
+              <a:spcBef>
+                <a:spcPts val="400"/>
+              </a:spcBef>
+              <a:defRPr sz="1100">
+                <a:solidFill>
+                  <a:srgbClr val="E2E8F0"/>
+                </a:solidFill>
+              </a:defRPr>
+            </a:pPr>
+            <a:r>
+              <a:t>/api/charts — bar, scatter, KPI aggregates</a:t>
+            </a:r>
+          </a:p>
+          <a:p>
+            <a:pPr>
+              <a:spcBef>
+                <a:spcPts val="400"/>
+              </a:spcBef>
+              <a:defRPr sz="1100">
+                <a:solidFill>
+                  <a:srgbClr val="E2E8F0"/>
+                </a:solidFill>
+              </a:defRPr>
+            </a:pPr>
+            <a:r>
+              <a:t>/api/warehouse/statistics — filtered table + pagination</a:t>
+            </a:r>
+          </a:p>
+          <a:p>
+            <a:pPr>
+              <a:spcBef>
+                <a:spcPts val="400"/>
+              </a:spcBef>
+              <a:defRPr sz="1100">
+                <a:solidFill>
+                  <a:srgbClr val="E2E8F0"/>
+                </a:solidFill>
+              </a:defRPr>
+            </a:pPr>
+            <a:r>
+              <a:t>/api/sprints — Plane tasks, agent status, watcher control</a:t>
+            </a:r>
+          </a:p>
+          <a:p>
+            <a:pPr>
+              <a:spcBef>
+                <a:spcPts val="400"/>
+              </a:spcBef>
+              <a:defRPr sz="1100">
+                <a:solidFill>
+                  <a:srgbClr val="E2E8F0"/>
+                </a:solidFill>
+              </a:defRPr>
+            </a:pPr>
+            <a:r>
+              <a:t>/api/mcp — MCP server registry &amp; health</a:t>
+            </a:r>
+          </a:p>
+          <a:p>
+            <a:pPr>
+              <a:spcBef>
+                <a:spcPts val="400"/>
+              </a:spcBef>
+              <a:defRPr sz="1100">
+                <a:solidFill>
+                  <a:srgbClr val="E2E8F0"/>
+                </a:solidFill>
+              </a:defRPr>
+            </a:pPr>
+            <a:r>
+              <a:t>/api/agents/status — pipeline + task queue telemetry</a:t>
+            </a:r>
+          </a:p>
+          <a:p>
+            <a:pPr>
+              <a:spcBef>
+                <a:spcPts val="400"/>
+              </a:spcBef>
+              <a:defRPr sz="1100">
+                <a:solidFill>
+                  <a:srgbClr val="E2E8F0"/>
+                </a:solidFill>
+              </a:defRPr>
+            </a:pPr>
+            <a:r>
+              <a:t>/api/health — uptime probe for tests &amp; monitor</a:t>
             </a:r>
           </a:p>
         </p:txBody>
@@ -4372,8 +4433,8 @@
         </p:nvSpPr>
         <p:spPr>
           <a:xfrm>
-            <a:off x="457200" y="2121408"/>
-            <a:ext cx="11064240" cy="749808"/>
+            <a:off x="6035040" y="1280160"/>
+            <a:ext cx="5394960" cy="4572000"/>
           </a:xfrm>
           <a:prstGeom prst="roundRect">
             <a:avLst/>
@@ -4383,7 +4444,7 @@
           </a:solidFill>
           <a:ln w="19050">
             <a:solidFill>
-              <a:srgbClr val="A78BFA"/>
+              <a:srgbClr val="7C3AED"/>
             </a:solidFill>
           </a:ln>
         </p:spPr>
@@ -4417,8 +4478,8 @@
         </p:nvSpPr>
         <p:spPr>
           <a:xfrm>
-            <a:off x="594360" y="2231136"/>
-            <a:ext cx="10789920" cy="566928"/>
+            <a:off x="6172200" y="1389888"/>
+            <a:ext cx="5120640" cy="4389120"/>
           </a:xfrm>
           <a:prstGeom prst="rect">
             <a:avLst/>
@@ -4434,12 +4495,12 @@
             <a:pPr>
               <a:defRPr b="1" sz="1400">
                 <a:solidFill>
-                  <a:srgbClr val="A78BFA"/>
-                </a:solidFill>
-              </a:defRPr>
-            </a:pPr>
-            <a:r>
-              <a:t>API Layer</a:t>
+                  <a:srgbClr val="7C3AED"/>
+                </a:solidFill>
+              </a:defRPr>
+            </a:pPr>
+            <a:r>
+              <a:t>Design Highlights</a:t>
             </a:r>
           </a:p>
           <a:p>
@@ -4454,87 +4515,7 @@
               </a:defRPr>
             </a:pPr>
             <a:r>
-              <a:t>FastAPI + Uvicorn (:8000) — REST routers, CORS, OpenAPI docs</a:t>
-            </a:r>
-          </a:p>
-        </p:txBody>
-      </p:sp>
-      <p:sp>
-        <p:nvSpPr>
-          <p:cNvPr id="8" name="Rounded Rectangle 7"/>
-          <p:cNvSpPr/>
-          <p:nvPr/>
-        </p:nvSpPr>
-        <p:spPr>
-          <a:xfrm>
-            <a:off x="457200" y="2962656"/>
-            <a:ext cx="11064240" cy="749808"/>
-          </a:xfrm>
-          <a:prstGeom prst="roundRect">
-            <a:avLst/>
-          </a:prstGeom>
-          <a:solidFill>
-            <a:srgbClr val="1E1B4B"/>
-          </a:solidFill>
-          <a:ln w="19050">
-            <a:solidFill>
-              <a:srgbClr val="A78BFA"/>
-            </a:solidFill>
-          </a:ln>
-        </p:spPr>
-        <p:style>
-          <a:lnRef idx="1">
-            <a:schemeClr val="accent1"/>
-          </a:lnRef>
-          <a:fillRef idx="3">
-            <a:schemeClr val="accent1"/>
-          </a:fillRef>
-          <a:effectRef idx="2">
-            <a:schemeClr val="accent1"/>
-          </a:effectRef>
-          <a:fontRef idx="minor">
-            <a:schemeClr val="lt1"/>
-          </a:fontRef>
-        </p:style>
-        <p:txBody>
-          <a:bodyPr rtlCol="0" anchor="ctr"/>
-          <a:lstStyle/>
-          <a:p>
-            <a:pPr algn="ctr"/>
-          </a:p>
-        </p:txBody>
-      </p:sp>
-      <p:sp>
-        <p:nvSpPr>
-          <p:cNvPr id="9" name="TextBox 8"/>
-          <p:cNvSpPr txBox="1"/>
-          <p:nvPr/>
-        </p:nvSpPr>
-        <p:spPr>
-          <a:xfrm>
-            <a:off x="594360" y="3072384"/>
-            <a:ext cx="10789920" cy="566928"/>
-          </a:xfrm>
-          <a:prstGeom prst="rect">
-            <a:avLst/>
-          </a:prstGeom>
-          <a:noFill/>
-        </p:spPr>
-        <p:txBody>
-          <a:bodyPr wrap="square">
-            <a:spAutoFit/>
-          </a:bodyPr>
-          <a:lstStyle/>
-          <a:p>
-            <a:pPr>
-              <a:defRPr b="1" sz="1400">
-                <a:solidFill>
-                  <a:srgbClr val="A78BFA"/>
-                </a:solidFill>
-              </a:defRPr>
-            </a:pPr>
-            <a:r>
-              <a:t>Agent Fleet</a:t>
+              <a:t>CORS enabled for Vite frontend</a:t>
             </a:r>
           </a:p>
           <a:p>
@@ -4549,87 +4530,7 @@
               </a:defRPr>
             </a:pPr>
             <a:r>
-              <a:t>Sprint Watcher · Builder · Tester · Git · Orchestrator</a:t>
-            </a:r>
-          </a:p>
-        </p:txBody>
-      </p:sp>
-      <p:sp>
-        <p:nvSpPr>
-          <p:cNvPr id="10" name="Rounded Rectangle 9"/>
-          <p:cNvSpPr/>
-          <p:nvPr/>
-        </p:nvSpPr>
-        <p:spPr>
-          <a:xfrm>
-            <a:off x="457200" y="3803904"/>
-            <a:ext cx="11064240" cy="749808"/>
-          </a:xfrm>
-          <a:prstGeom prst="roundRect">
-            <a:avLst/>
-          </a:prstGeom>
-          <a:solidFill>
-            <a:srgbClr val="1E1B4B"/>
-          </a:solidFill>
-          <a:ln w="19050">
-            <a:solidFill>
-              <a:srgbClr val="A78BFA"/>
-            </a:solidFill>
-          </a:ln>
-        </p:spPr>
-        <p:style>
-          <a:lnRef idx="1">
-            <a:schemeClr val="accent1"/>
-          </a:lnRef>
-          <a:fillRef idx="3">
-            <a:schemeClr val="accent1"/>
-          </a:fillRef>
-          <a:effectRef idx="2">
-            <a:schemeClr val="accent1"/>
-          </a:effectRef>
-          <a:fontRef idx="minor">
-            <a:schemeClr val="lt1"/>
-          </a:fontRef>
-        </p:style>
-        <p:txBody>
-          <a:bodyPr rtlCol="0" anchor="ctr"/>
-          <a:lstStyle/>
-          <a:p>
-            <a:pPr algn="ctr"/>
-          </a:p>
-        </p:txBody>
-      </p:sp>
-      <p:sp>
-        <p:nvSpPr>
-          <p:cNvPr id="11" name="TextBox 10"/>
-          <p:cNvSpPr txBox="1"/>
-          <p:nvPr/>
-        </p:nvSpPr>
-        <p:spPr>
-          <a:xfrm>
-            <a:off x="594360" y="3913632"/>
-            <a:ext cx="10789920" cy="566928"/>
-          </a:xfrm>
-          <a:prstGeom prst="rect">
-            <a:avLst/>
-          </a:prstGeom>
-          <a:noFill/>
-        </p:spPr>
-        <p:txBody>
-          <a:bodyPr wrap="square">
-            <a:spAutoFit/>
-          </a:bodyPr>
-          <a:lstStyle/>
-          <a:p>
-            <a:pPr>
-              <a:defRPr b="1" sz="1400">
-                <a:solidFill>
-                  <a:srgbClr val="A78BFA"/>
-                </a:solidFill>
-              </a:defRPr>
-            </a:pPr>
-            <a:r>
-              <a:t>MCP Bridge</a:t>
+              <a:t>Dual search: Global Header (date+DB+whse) vs Copilot (no date)</a:t>
             </a:r>
           </a:p>
           <a:p>
@@ -4644,87 +4545,7 @@
               </a:defRPr>
             </a:pPr>
             <a:r>
-              <a:t>plane · github · memory · browser — tool registry in mcp_config.json</a:t>
-            </a:r>
-          </a:p>
-        </p:txBody>
-      </p:sp>
-      <p:sp>
-        <p:nvSpPr>
-          <p:cNvPr id="12" name="Rounded Rectangle 11"/>
-          <p:cNvSpPr/>
-          <p:nvPr/>
-        </p:nvSpPr>
-        <p:spPr>
-          <a:xfrm>
-            <a:off x="457200" y="4645152"/>
-            <a:ext cx="11064240" cy="749808"/>
-          </a:xfrm>
-          <a:prstGeom prst="roundRect">
-            <a:avLst/>
-          </a:prstGeom>
-          <a:solidFill>
-            <a:srgbClr val="1E1B4B"/>
-          </a:solidFill>
-          <a:ln w="19050">
-            <a:solidFill>
-              <a:srgbClr val="A78BFA"/>
-            </a:solidFill>
-          </a:ln>
-        </p:spPr>
-        <p:style>
-          <a:lnRef idx="1">
-            <a:schemeClr val="accent1"/>
-          </a:lnRef>
-          <a:fillRef idx="3">
-            <a:schemeClr val="accent1"/>
-          </a:fillRef>
-          <a:effectRef idx="2">
-            <a:schemeClr val="accent1"/>
-          </a:effectRef>
-          <a:fontRef idx="minor">
-            <a:schemeClr val="lt1"/>
-          </a:fontRef>
-        </p:style>
-        <p:txBody>
-          <a:bodyPr rtlCol="0" anchor="ctr"/>
-          <a:lstStyle/>
-          <a:p>
-            <a:pPr algn="ctr"/>
-          </a:p>
-        </p:txBody>
-      </p:sp>
-      <p:sp>
-        <p:nvSpPr>
-          <p:cNvPr id="13" name="TextBox 12"/>
-          <p:cNvSpPr txBox="1"/>
-          <p:nvPr/>
-        </p:nvSpPr>
-        <p:spPr>
-          <a:xfrm>
-            <a:off x="594360" y="4754880"/>
-            <a:ext cx="10789920" cy="566928"/>
-          </a:xfrm>
-          <a:prstGeom prst="rect">
-            <a:avLst/>
-          </a:prstGeom>
-          <a:noFill/>
-        </p:spPr>
-        <p:txBody>
-          <a:bodyPr wrap="square">
-            <a:spAutoFit/>
-          </a:bodyPr>
-          <a:lstStyle/>
-          <a:p>
-            <a:pPr>
-              <a:defRPr b="1" sz="1400">
-                <a:solidFill>
-                  <a:srgbClr val="A78BFA"/>
-                </a:solidFill>
-              </a:defRPr>
-            </a:pPr>
-            <a:r>
-              <a:t>Data</a:t>
+              <a:t>Parameter propagation: oerdte, target_db, oewhse → all widgets</a:t>
             </a:r>
           </a:p>
           <a:p>
@@ -4739,87 +4560,7 @@
               </a:defRPr>
             </a:pPr>
             <a:r>
-              <a:t>PostgreSQL · Oracle DEV/F1 · warehouse_seed.json fallback</a:t>
-            </a:r>
-          </a:p>
-        </p:txBody>
-      </p:sp>
-      <p:sp>
-        <p:nvSpPr>
-          <p:cNvPr id="14" name="Rounded Rectangle 13"/>
-          <p:cNvSpPr/>
-          <p:nvPr/>
-        </p:nvSpPr>
-        <p:spPr>
-          <a:xfrm>
-            <a:off x="457200" y="5486400"/>
-            <a:ext cx="11064240" cy="749808"/>
-          </a:xfrm>
-          <a:prstGeom prst="roundRect">
-            <a:avLst/>
-          </a:prstGeom>
-          <a:solidFill>
-            <a:srgbClr val="1E1B4B"/>
-          </a:solidFill>
-          <a:ln w="19050">
-            <a:solidFill>
-              <a:srgbClr val="A78BFA"/>
-            </a:solidFill>
-          </a:ln>
-        </p:spPr>
-        <p:style>
-          <a:lnRef idx="1">
-            <a:schemeClr val="accent1"/>
-          </a:lnRef>
-          <a:fillRef idx="3">
-            <a:schemeClr val="accent1"/>
-          </a:fillRef>
-          <a:effectRef idx="2">
-            <a:schemeClr val="accent1"/>
-          </a:effectRef>
-          <a:fontRef idx="minor">
-            <a:schemeClr val="lt1"/>
-          </a:fontRef>
-        </p:style>
-        <p:txBody>
-          <a:bodyPr rtlCol="0" anchor="ctr"/>
-          <a:lstStyle/>
-          <a:p>
-            <a:pPr algn="ctr"/>
-          </a:p>
-        </p:txBody>
-      </p:sp>
-      <p:sp>
-        <p:nvSpPr>
-          <p:cNvPr id="15" name="TextBox 14"/>
-          <p:cNvSpPr txBox="1"/>
-          <p:nvPr/>
-        </p:nvSpPr>
-        <p:spPr>
-          <a:xfrm>
-            <a:off x="594360" y="5596128"/>
-            <a:ext cx="10789920" cy="566928"/>
-          </a:xfrm>
-          <a:prstGeom prst="rect">
-            <a:avLst/>
-          </a:prstGeom>
-          <a:noFill/>
-        </p:spPr>
-        <p:txBody>
-          <a:bodyPr wrap="square">
-            <a:spAutoFit/>
-          </a:bodyPr>
-          <a:lstStyle/>
-          <a:p>
-            <a:pPr>
-              <a:defRPr b="1" sz="1400">
-                <a:solidFill>
-                  <a:srgbClr val="A78BFA"/>
-                </a:solidFill>
-              </a:defRPr>
-            </a:pPr>
-            <a:r>
-              <a:t>External PM</a:t>
+              <a:t>Sprint API caches Plane responses (rate-limit safe)</a:t>
             </a:r>
           </a:p>
           <a:p>
@@ -4834,14 +4575,29 @@
               </a:defRPr>
             </a:pPr>
             <a:r>
-              <a:t>Plane REST API — tasks, sprints, comments, status</a:t>
-            </a:r>
-          </a:p>
-        </p:txBody>
-      </p:sp>
-      <p:sp>
-        <p:nvSpPr>
-          <p:cNvPr id="16" name="TextBox 15"/>
+              <a:t>Warehouse service: live DB + local seed fallback</a:t>
+            </a:r>
+          </a:p>
+          <a:p>
+            <a:pPr>
+              <a:spcBef>
+                <a:spcPts val="400"/>
+              </a:spcBef>
+              <a:defRPr sz="1100">
+                <a:solidFill>
+                  <a:srgbClr val="E2E8F0"/>
+                </a:solidFill>
+              </a:defRPr>
+            </a:pPr>
+            <a:r>
+              <a:t>Serves Agent Monitor UI with live JSON state</a:t>
+            </a:r>
+          </a:p>
+        </p:txBody>
+      </p:sp>
+      <p:sp>
+        <p:nvSpPr>
+          <p:cNvPr id="8" name="TextBox 7"/>
           <p:cNvSpPr txBox="1"/>
           <p:nvPr/>
         </p:nvSpPr>
@@ -4973,7 +4729,7 @@
               </a:defRPr>
             </a:pPr>
             <a:r>
-              <a:t>FastAPI Backend</a:t>
+              <a:t>Model Context Protocol (MCP)</a:t>
             </a:r>
           </a:p>
           <a:p>
@@ -4988,7 +4744,7 @@
               </a:defRPr>
             </a:pPr>
             <a:r>
-              <a:t>Python 3.10 · backend/main.py · OpenAPI at /docs</a:t>
+              <a:t>Standardized tool bridge — agents/mcp_client.py + mcp_config.json</a:t>
             </a:r>
           </a:p>
         </p:txBody>
@@ -5001,8 +4757,8 @@
         </p:nvSpPr>
         <p:spPr>
           <a:xfrm>
-            <a:off x="457200" y="1280160"/>
-            <a:ext cx="5303520" cy="4572000"/>
+            <a:off x="457200" y="1325880"/>
+            <a:ext cx="5394960" cy="2148840"/>
           </a:xfrm>
           <a:prstGeom prst="roundRect">
             <a:avLst/>
@@ -5012,7 +4768,7 @@
           </a:solidFill>
           <a:ln w="19050">
             <a:solidFill>
-              <a:srgbClr val="3B82F6"/>
+              <a:srgbClr val="A78BFA"/>
             </a:solidFill>
           </a:ln>
         </p:spPr>
@@ -5046,8 +4802,8 @@
         </p:nvSpPr>
         <p:spPr>
           <a:xfrm>
-            <a:off x="594360" y="1389888"/>
-            <a:ext cx="5029200" cy="4389120"/>
+            <a:off x="594360" y="1435608"/>
+            <a:ext cx="5120640" cy="1965960"/>
           </a:xfrm>
           <a:prstGeom prst="rect">
             <a:avLst/>
@@ -5063,12 +4819,12 @@
             <a:pPr>
               <a:defRPr b="1" sz="1400">
                 <a:solidFill>
-                  <a:srgbClr val="3B82F6"/>
-                </a:solidFill>
-              </a:defRPr>
-            </a:pPr>
-            <a:r>
-              <a:t>Core Routers</a:t>
+                  <a:srgbClr val="A78BFA"/>
+                </a:solidFill>
+              </a:defRPr>
+            </a:pPr>
+            <a:r>
+              <a:t>Plane MCP</a:t>
             </a:r>
           </a:p>
           <a:p>
@@ -5083,7 +4839,7 @@
               </a:defRPr>
             </a:pPr>
             <a:r>
-              <a:t>/api/data — CSV/Excel upload, DB queries</a:t>
+              <a:t>Tools: list_tasks · update_task_status · add_comment · list_projects</a:t>
             </a:r>
           </a:p>
           <a:p>
@@ -5098,97 +4854,7 @@
               </a:defRPr>
             </a:pPr>
             <a:r>
-              <a:t>/api/analytics — AI Copilot (no-date NL search)</a:t>
-            </a:r>
-          </a:p>
-          <a:p>
-            <a:pPr>
-              <a:spcBef>
-                <a:spcPts val="400"/>
-              </a:spcBef>
-              <a:defRPr sz="1100">
-                <a:solidFill>
-                  <a:srgbClr val="E2E8F0"/>
-                </a:solidFill>
-              </a:defRPr>
-            </a:pPr>
-            <a:r>
-              <a:t>/api/charts — bar, scatter, KPI aggregates</a:t>
-            </a:r>
-          </a:p>
-          <a:p>
-            <a:pPr>
-              <a:spcBef>
-                <a:spcPts val="400"/>
-              </a:spcBef>
-              <a:defRPr sz="1100">
-                <a:solidFill>
-                  <a:srgbClr val="E2E8F0"/>
-                </a:solidFill>
-              </a:defRPr>
-            </a:pPr>
-            <a:r>
-              <a:t>/api/warehouse/statistics — filtered table + pagination</a:t>
-            </a:r>
-          </a:p>
-          <a:p>
-            <a:pPr>
-              <a:spcBef>
-                <a:spcPts val="400"/>
-              </a:spcBef>
-              <a:defRPr sz="1100">
-                <a:solidFill>
-                  <a:srgbClr val="E2E8F0"/>
-                </a:solidFill>
-              </a:defRPr>
-            </a:pPr>
-            <a:r>
-              <a:t>/api/sprints — Plane tasks, agent status, watcher control</a:t>
-            </a:r>
-          </a:p>
-          <a:p>
-            <a:pPr>
-              <a:spcBef>
-                <a:spcPts val="400"/>
-              </a:spcBef>
-              <a:defRPr sz="1100">
-                <a:solidFill>
-                  <a:srgbClr val="E2E8F0"/>
-                </a:solidFill>
-              </a:defRPr>
-            </a:pPr>
-            <a:r>
-              <a:t>/api/mcp — MCP server registry &amp; health</a:t>
-            </a:r>
-          </a:p>
-          <a:p>
-            <a:pPr>
-              <a:spcBef>
-                <a:spcPts val="400"/>
-              </a:spcBef>
-              <a:defRPr sz="1100">
-                <a:solidFill>
-                  <a:srgbClr val="E2E8F0"/>
-                </a:solidFill>
-              </a:defRPr>
-            </a:pPr>
-            <a:r>
-              <a:t>/api/agents/status — pipeline + task queue telemetry</a:t>
-            </a:r>
-          </a:p>
-          <a:p>
-            <a:pPr>
-              <a:spcBef>
-                <a:spcPts val="400"/>
-              </a:spcBef>
-              <a:defRPr sz="1100">
-                <a:solidFill>
-                  <a:srgbClr val="E2E8F0"/>
-                </a:solidFill>
-              </a:defRPr>
-            </a:pPr>
-            <a:r>
-              <a:t>/api/health — uptime probe for tests &amp; monitor</a:t>
+              <a:t>Used by: Sprint Watcher, Plane Agent</a:t>
             </a:r>
           </a:p>
         </p:txBody>
@@ -5201,8 +4867,8 @@
         </p:nvSpPr>
         <p:spPr>
           <a:xfrm>
-            <a:off x="6035040" y="1280160"/>
-            <a:ext cx="5394960" cy="4572000"/>
+            <a:off x="6126480" y="1325880"/>
+            <a:ext cx="5394960" cy="2148840"/>
           </a:xfrm>
           <a:prstGeom prst="roundRect">
             <a:avLst/>
@@ -5212,7 +4878,7 @@
           </a:solidFill>
           <a:ln w="19050">
             <a:solidFill>
-              <a:srgbClr val="7C3AED"/>
+              <a:srgbClr val="34D399"/>
             </a:solidFill>
           </a:ln>
         </p:spPr>
@@ -5246,8 +4912,8 @@
         </p:nvSpPr>
         <p:spPr>
           <a:xfrm>
-            <a:off x="6172200" y="1389888"/>
-            <a:ext cx="5120640" cy="4389120"/>
+            <a:off x="6263640" y="1435608"/>
+            <a:ext cx="5120640" cy="1965960"/>
           </a:xfrm>
           <a:prstGeom prst="rect">
             <a:avLst/>
@@ -5263,12 +4929,12 @@
             <a:pPr>
               <a:defRPr b="1" sz="1400">
                 <a:solidFill>
-                  <a:srgbClr val="7C3AED"/>
-                </a:solidFill>
-              </a:defRPr>
-            </a:pPr>
-            <a:r>
-              <a:t>Design Highlights</a:t>
+                  <a:srgbClr val="34D399"/>
+                </a:solidFill>
+              </a:defRPr>
+            </a:pPr>
+            <a:r>
+              <a:t>GitHub MCP</a:t>
             </a:r>
           </a:p>
           <a:p>
@@ -5283,7 +4949,7 @@
               </a:defRPr>
             </a:pPr>
             <a:r>
-              <a:t>CORS enabled for Vite frontend</a:t>
+              <a:t>Tools: git_commit · git_push · get_meaningful_changed_files</a:t>
             </a:r>
           </a:p>
           <a:p>
@@ -5298,7 +4964,87 @@
               </a:defRPr>
             </a:pPr>
             <a:r>
-              <a:t>Dual search: Global Header (date+DB+whse) vs Copilot (no date)</a:t>
+              <a:t>Used by: Git Agent after task close</a:t>
+            </a:r>
+          </a:p>
+        </p:txBody>
+      </p:sp>
+      <p:sp>
+        <p:nvSpPr>
+          <p:cNvPr id="8" name="Rounded Rectangle 7"/>
+          <p:cNvSpPr/>
+          <p:nvPr/>
+        </p:nvSpPr>
+        <p:spPr>
+          <a:xfrm>
+            <a:off x="457200" y="3657600"/>
+            <a:ext cx="5394960" cy="2148840"/>
+          </a:xfrm>
+          <a:prstGeom prst="roundRect">
+            <a:avLst/>
+          </a:prstGeom>
+          <a:solidFill>
+            <a:srgbClr val="1E1B4B"/>
+          </a:solidFill>
+          <a:ln w="19050">
+            <a:solidFill>
+              <a:srgbClr val="A78BFA"/>
+            </a:solidFill>
+          </a:ln>
+        </p:spPr>
+        <p:style>
+          <a:lnRef idx="1">
+            <a:schemeClr val="accent1"/>
+          </a:lnRef>
+          <a:fillRef idx="3">
+            <a:schemeClr val="accent1"/>
+          </a:fillRef>
+          <a:effectRef idx="2">
+            <a:schemeClr val="accent1"/>
+          </a:effectRef>
+          <a:fontRef idx="minor">
+            <a:schemeClr val="lt1"/>
+          </a:fontRef>
+        </p:style>
+        <p:txBody>
+          <a:bodyPr rtlCol="0" anchor="ctr"/>
+          <a:lstStyle/>
+          <a:p>
+            <a:pPr algn="ctr"/>
+          </a:p>
+        </p:txBody>
+      </p:sp>
+      <p:sp>
+        <p:nvSpPr>
+          <p:cNvPr id="9" name="TextBox 8"/>
+          <p:cNvSpPr txBox="1"/>
+          <p:nvPr/>
+        </p:nvSpPr>
+        <p:spPr>
+          <a:xfrm>
+            <a:off x="594360" y="3767328"/>
+            <a:ext cx="5120640" cy="1965960"/>
+          </a:xfrm>
+          <a:prstGeom prst="rect">
+            <a:avLst/>
+          </a:prstGeom>
+          <a:noFill/>
+        </p:spPr>
+        <p:txBody>
+          <a:bodyPr wrap="square">
+            <a:spAutoFit/>
+          </a:bodyPr>
+          <a:lstStyle/>
+          <a:p>
+            <a:pPr>
+              <a:defRPr b="1" sz="1400">
+                <a:solidFill>
+                  <a:srgbClr val="A78BFA"/>
+                </a:solidFill>
+              </a:defRPr>
+            </a:pPr>
+            <a:r>
+              <a:t>Memory MCP</a:t>
             </a:r>
           </a:p>
           <a:p>
@@ -5313,7 +5059,7 @@
               </a:defRPr>
             </a:pPr>
             <a:r>
-              <a:t>Parameter propagation: oerdte, target_db, oewhse → all widgets</a:t>
+              <a:t>Tools: load_state · set_pipeline_status · get_task_queue · log_task_result</a:t>
             </a:r>
           </a:p>
           <a:p>
@@ -5328,7 +5074,87 @@
               </a:defRPr>
             </a:pPr>
             <a:r>
-              <a:t>Sprint API caches Plane responses (rate-limit safe)</a:t>
+              <a:t>Used by: All agents + UI</a:t>
+            </a:r>
+          </a:p>
+        </p:txBody>
+      </p:sp>
+      <p:sp>
+        <p:nvSpPr>
+          <p:cNvPr id="10" name="Rounded Rectangle 9"/>
+          <p:cNvSpPr/>
+          <p:nvPr/>
+        </p:nvSpPr>
+        <p:spPr>
+          <a:xfrm>
+            <a:off x="6126480" y="3657600"/>
+            <a:ext cx="5394960" cy="2148840"/>
+          </a:xfrm>
+          <a:prstGeom prst="roundRect">
+            <a:avLst/>
+          </a:prstGeom>
+          <a:solidFill>
+            <a:srgbClr val="1E1B4B"/>
+          </a:solidFill>
+          <a:ln w="19050">
+            <a:solidFill>
+              <a:srgbClr val="34D399"/>
+            </a:solidFill>
+          </a:ln>
+        </p:spPr>
+        <p:style>
+          <a:lnRef idx="1">
+            <a:schemeClr val="accent1"/>
+          </a:lnRef>
+          <a:fillRef idx="3">
+            <a:schemeClr val="accent1"/>
+          </a:fillRef>
+          <a:effectRef idx="2">
+            <a:schemeClr val="accent1"/>
+          </a:effectRef>
+          <a:fontRef idx="minor">
+            <a:schemeClr val="lt1"/>
+          </a:fontRef>
+        </p:style>
+        <p:txBody>
+          <a:bodyPr rtlCol="0" anchor="ctr"/>
+          <a:lstStyle/>
+          <a:p>
+            <a:pPr algn="ctr"/>
+          </a:p>
+        </p:txBody>
+      </p:sp>
+      <p:sp>
+        <p:nvSpPr>
+          <p:cNvPr id="11" name="TextBox 10"/>
+          <p:cNvSpPr txBox="1"/>
+          <p:nvPr/>
+        </p:nvSpPr>
+        <p:spPr>
+          <a:xfrm>
+            <a:off x="6263640" y="3767328"/>
+            <a:ext cx="5120640" cy="1965960"/>
+          </a:xfrm>
+          <a:prstGeom prst="rect">
+            <a:avLst/>
+          </a:prstGeom>
+          <a:noFill/>
+        </p:spPr>
+        <p:txBody>
+          <a:bodyPr wrap="square">
+            <a:spAutoFit/>
+          </a:bodyPr>
+          <a:lstStyle/>
+          <a:p>
+            <a:pPr>
+              <a:defRPr b="1" sz="1400">
+                <a:solidFill>
+                  <a:srgbClr val="34D399"/>
+                </a:solidFill>
+              </a:defRPr>
+            </a:pPr>
+            <a:r>
+              <a:t>Browser MCP</a:t>
             </a:r>
           </a:p>
           <a:p>
@@ -5343,7 +5169,7 @@
               </a:defRPr>
             </a:pPr>
             <a:r>
-              <a:t>Warehouse service: live DB + local seed fallback</a:t>
+              <a:t>Tools: run_unit_tests · run_browser_tests · run_sprint_task_tests</a:t>
             </a:r>
           </a:p>
           <a:p>
@@ -5358,14 +5184,49 @@
               </a:defRPr>
             </a:pPr>
             <a:r>
-              <a:t>Serves Agent Monitor UI with live JSON state</a:t>
-            </a:r>
-          </a:p>
-        </p:txBody>
-      </p:sp>
-      <p:sp>
-        <p:nvSpPr>
-          <p:cNvPr id="8" name="TextBox 7"/>
+              <a:t>Used by: Tester Agent quality gate</a:t>
+            </a:r>
+          </a:p>
+        </p:txBody>
+      </p:sp>
+      <p:sp>
+        <p:nvSpPr>
+          <p:cNvPr id="12" name="TextBox 11"/>
+          <p:cNvSpPr txBox="1"/>
+          <p:nvPr/>
+        </p:nvSpPr>
+        <p:spPr>
+          <a:xfrm>
+            <a:off x="457200" y="5989320"/>
+            <a:ext cx="10972800" cy="411480"/>
+          </a:xfrm>
+          <a:prstGeom prst="rect">
+            <a:avLst/>
+          </a:prstGeom>
+          <a:noFill/>
+        </p:spPr>
+        <p:txBody>
+          <a:bodyPr wrap="none">
+            <a:spAutoFit/>
+          </a:bodyPr>
+          <a:lstStyle/>
+          <a:p>
+            <a:pPr algn="ctr">
+              <a:defRPr sz="1100">
+                <a:solidFill>
+                  <a:srgbClr val="94A3B8"/>
+                </a:solidFill>
+              </a:defRPr>
+            </a:pPr>
+            <a:r>
+              <a:t>MCP decouples agents from integrations — swap Plane/GitHub/test backends without changing UI or watcher logic</a:t>
+            </a:r>
+          </a:p>
+        </p:txBody>
+      </p:sp>
+      <p:sp>
+        <p:nvSpPr>
+          <p:cNvPr id="13" name="TextBox 12"/>
           <p:cNvSpPr txBox="1"/>
           <p:nvPr/>
         </p:nvSpPr>
@@ -5497,7 +5358,7 @@
               </a:defRPr>
             </a:pPr>
             <a:r>
-              <a:t>Model Context Protocol (MCP)</a:t>
+              <a:t>Data Flow — Dashboard to Database</a:t>
             </a:r>
           </a:p>
           <a:p>
@@ -5512,66 +5373,21 @@
               </a:defRPr>
             </a:pPr>
             <a:r>
-              <a:t>Standardized tool bridge — agents/mcp_client.py + mcp_config.json</a:t>
-            </a:r>
-          </a:p>
-        </p:txBody>
-      </p:sp>
-      <p:sp>
-        <p:nvSpPr>
-          <p:cNvPr id="4" name="Rounded Rectangle 3"/>
-          <p:cNvSpPr/>
-          <p:nvPr/>
-        </p:nvSpPr>
-        <p:spPr>
-          <a:xfrm>
-            <a:off x="457200" y="1325880"/>
-            <a:ext cx="5394960" cy="2148840"/>
-          </a:xfrm>
-          <a:prstGeom prst="roundRect">
-            <a:avLst/>
-          </a:prstGeom>
-          <a:solidFill>
-            <a:srgbClr val="1E1B4B"/>
-          </a:solidFill>
-          <a:ln w="19050">
-            <a:solidFill>
-              <a:srgbClr val="A78BFA"/>
-            </a:solidFill>
-          </a:ln>
-        </p:spPr>
-        <p:style>
-          <a:lnRef idx="1">
-            <a:schemeClr val="accent1"/>
-          </a:lnRef>
-          <a:fillRef idx="3">
-            <a:schemeClr val="accent1"/>
-          </a:fillRef>
-          <a:effectRef idx="2">
-            <a:schemeClr val="accent1"/>
-          </a:effectRef>
-          <a:fontRef idx="minor">
-            <a:schemeClr val="lt1"/>
-          </a:fontRef>
-        </p:style>
-        <p:txBody>
-          <a:bodyPr rtlCol="0" anchor="ctr"/>
-          <a:lstStyle/>
-          <a:p>
-            <a:pPr algn="ctr"/>
-          </a:p>
-        </p:txBody>
-      </p:sp>
-      <p:sp>
-        <p:nvSpPr>
-          <p:cNvPr id="5" name="TextBox 4"/>
+              <a:t>Single-warehouse filtering · dual search modes</a:t>
+            </a:r>
+          </a:p>
+        </p:txBody>
+      </p:sp>
+      <p:sp>
+        <p:nvSpPr>
+          <p:cNvPr id="4" name="TextBox 3"/>
           <p:cNvSpPr txBox="1"/>
           <p:nvPr/>
         </p:nvSpPr>
         <p:spPr>
           <a:xfrm>
-            <a:off x="594360" y="1435608"/>
-            <a:ext cx="5120640" cy="1965960"/>
+            <a:off x="640080" y="1371600"/>
+            <a:ext cx="10789920" cy="4754880"/>
           </a:xfrm>
           <a:prstGeom prst="rect">
             <a:avLst/>
@@ -5585,416 +5401,96 @@
           <a:lstStyle/>
           <a:p>
             <a:pPr>
-              <a:defRPr b="1" sz="1400">
-                <a:solidFill>
-                  <a:srgbClr val="A78BFA"/>
-                </a:solidFill>
-              </a:defRPr>
-            </a:pPr>
-            <a:r>
-              <a:t>Plane MCP</a:t>
+              <a:spcAft>
+                <a:spcPts val="1000"/>
+              </a:spcAft>
+              <a:defRPr sz="1400">
+                <a:solidFill>
+                  <a:srgbClr val="E2E8F0"/>
+                </a:solidFill>
+              </a:defRPr>
+            </a:pPr>
+            <a:r>
+              <a:t>• Global Header Submit → oerdte + target_db + oewhse → /api/charts/* + /api/warehouse/statistics</a:t>
             </a:r>
           </a:p>
           <a:p>
             <a:pPr>
               <a:spcBef>
-                <a:spcPts val="400"/>
+                <a:spcPts val="600"/>
               </a:spcBef>
-              <a:defRPr sz="1100">
+              <a:spcAft>
+                <a:spcPts val="1000"/>
+              </a:spcAft>
+              <a:defRPr sz="1400">
                 <a:solidFill>
                   <a:srgbClr val="E2E8F0"/>
                 </a:solidFill>
               </a:defRPr>
             </a:pPr>
             <a:r>
-              <a:t>Tools: list_tasks · update_task_status · add_comment · list_projects</a:t>
+              <a:t>• AI Copilot Ask → POST /api/analytics/ai-copilot with oerdte='' (all dates, NL intent)</a:t>
             </a:r>
           </a:p>
           <a:p>
             <a:pPr>
               <a:spcBef>
-                <a:spcPts val="400"/>
+                <a:spcPts val="600"/>
               </a:spcBef>
-              <a:defRPr sz="1100">
+              <a:spcAft>
+                <a:spcPts val="1000"/>
+              </a:spcAft>
+              <a:defRPr sz="1400">
                 <a:solidFill>
                   <a:srgbClr val="E2E8F0"/>
                 </a:solidFill>
               </a:defRPr>
             </a:pPr>
             <a:r>
-              <a:t>Used by: Sprint Watcher, Plane Agent</a:t>
-            </a:r>
-          </a:p>
-        </p:txBody>
-      </p:sp>
-      <p:sp>
-        <p:nvSpPr>
-          <p:cNvPr id="6" name="Rounded Rectangle 5"/>
-          <p:cNvSpPr/>
-          <p:nvPr/>
-        </p:nvSpPr>
-        <p:spPr>
-          <a:xfrm>
-            <a:off x="6126480" y="1325880"/>
-            <a:ext cx="5394960" cy="2148840"/>
-          </a:xfrm>
-          <a:prstGeom prst="roundRect">
-            <a:avLst/>
-          </a:prstGeom>
-          <a:solidFill>
-            <a:srgbClr val="1E1B4B"/>
-          </a:solidFill>
-          <a:ln w="19050">
-            <a:solidFill>
-              <a:srgbClr val="34D399"/>
-            </a:solidFill>
-          </a:ln>
-        </p:spPr>
-        <p:style>
-          <a:lnRef idx="1">
-            <a:schemeClr val="accent1"/>
-          </a:lnRef>
-          <a:fillRef idx="3">
-            <a:schemeClr val="accent1"/>
-          </a:fillRef>
-          <a:effectRef idx="2">
-            <a:schemeClr val="accent1"/>
-          </a:effectRef>
-          <a:fontRef idx="minor">
-            <a:schemeClr val="lt1"/>
-          </a:fontRef>
-        </p:style>
-        <p:txBody>
-          <a:bodyPr rtlCol="0" anchor="ctr"/>
-          <a:lstStyle/>
-          <a:p>
-            <a:pPr algn="ctr"/>
-          </a:p>
-        </p:txBody>
-      </p:sp>
-      <p:sp>
-        <p:nvSpPr>
-          <p:cNvPr id="7" name="TextBox 6"/>
-          <p:cNvSpPr txBox="1"/>
-          <p:nvPr/>
-        </p:nvSpPr>
-        <p:spPr>
-          <a:xfrm>
-            <a:off x="6263640" y="1435608"/>
-            <a:ext cx="5120640" cy="1965960"/>
-          </a:xfrm>
-          <a:prstGeom prst="rect">
-            <a:avLst/>
-          </a:prstGeom>
-          <a:noFill/>
-        </p:spPr>
-        <p:txBody>
-          <a:bodyPr wrap="square">
-            <a:spAutoFit/>
-          </a:bodyPr>
-          <a:lstStyle/>
-          <a:p>
-            <a:pPr>
-              <a:defRPr b="1" sz="1400">
-                <a:solidFill>
-                  <a:srgbClr val="34D399"/>
-                </a:solidFill>
-              </a:defRPr>
-            </a:pPr>
-            <a:r>
-              <a:t>GitHub MCP</a:t>
+              <a:t>• KPI cards, bar chart, scatter plot, warehouse table refresh from same filter context</a:t>
             </a:r>
           </a:p>
           <a:p>
             <a:pPr>
               <a:spcBef>
-                <a:spcPts val="400"/>
+                <a:spcPts val="600"/>
               </a:spcBef>
-              <a:defRPr sz="1100">
+              <a:spcAft>
+                <a:spcPts val="1000"/>
+              </a:spcAft>
+              <a:defRPr sz="1400">
                 <a:solidFill>
                   <a:srgbClr val="E2E8F0"/>
                 </a:solidFill>
               </a:defRPr>
             </a:pPr>
             <a:r>
-              <a:t>Tools: git_commit · git_push · get_meaningful_changed_files</a:t>
+              <a:t>• When warehouse selected: charts show ONLY that facility (Task 27 rule)</a:t>
             </a:r>
           </a:p>
           <a:p>
             <a:pPr>
               <a:spcBef>
-                <a:spcPts val="400"/>
+                <a:spcPts val="600"/>
               </a:spcBef>
-              <a:defRPr sz="1100">
+              <a:spcAft>
+                <a:spcPts val="1000"/>
+              </a:spcAft>
+              <a:defRPr sz="1400">
                 <a:solidFill>
                   <a:srgbClr val="E2E8F0"/>
                 </a:solidFill>
               </a:defRPr>
             </a:pPr>
             <a:r>
-              <a:t>Used by: Git Agent after task close</a:t>
-            </a:r>
-          </a:p>
-        </p:txBody>
-      </p:sp>
-      <p:sp>
-        <p:nvSpPr>
-          <p:cNvPr id="8" name="Rounded Rectangle 7"/>
-          <p:cNvSpPr/>
-          <p:nvPr/>
-        </p:nvSpPr>
-        <p:spPr>
-          <a:xfrm>
-            <a:off x="457200" y="3657600"/>
-            <a:ext cx="5394960" cy="2148840"/>
-          </a:xfrm>
-          <a:prstGeom prst="roundRect">
-            <a:avLst/>
-          </a:prstGeom>
-          <a:solidFill>
-            <a:srgbClr val="1E1B4B"/>
-          </a:solidFill>
-          <a:ln w="19050">
-            <a:solidFill>
-              <a:srgbClr val="A78BFA"/>
-            </a:solidFill>
-          </a:ln>
-        </p:spPr>
-        <p:style>
-          <a:lnRef idx="1">
-            <a:schemeClr val="accent1"/>
-          </a:lnRef>
-          <a:fillRef idx="3">
-            <a:schemeClr val="accent1"/>
-          </a:fillRef>
-          <a:effectRef idx="2">
-            <a:schemeClr val="accent1"/>
-          </a:effectRef>
-          <a:fontRef idx="minor">
-            <a:schemeClr val="lt1"/>
-          </a:fontRef>
-        </p:style>
-        <p:txBody>
-          <a:bodyPr rtlCol="0" anchor="ctr"/>
-          <a:lstStyle/>
-          <a:p>
-            <a:pPr algn="ctr"/>
-          </a:p>
-        </p:txBody>
-      </p:sp>
-      <p:sp>
-        <p:nvSpPr>
-          <p:cNvPr id="9" name="TextBox 8"/>
-          <p:cNvSpPr txBox="1"/>
-          <p:nvPr/>
-        </p:nvSpPr>
-        <p:spPr>
-          <a:xfrm>
-            <a:off x="594360" y="3767328"/>
-            <a:ext cx="5120640" cy="1965960"/>
-          </a:xfrm>
-          <a:prstGeom prst="rect">
-            <a:avLst/>
-          </a:prstGeom>
-          <a:noFill/>
-        </p:spPr>
-        <p:txBody>
-          <a:bodyPr wrap="square">
-            <a:spAutoFit/>
-          </a:bodyPr>
-          <a:lstStyle/>
-          <a:p>
-            <a:pPr>
-              <a:defRPr b="1" sz="1400">
-                <a:solidFill>
-                  <a:srgbClr val="A78BFA"/>
-                </a:solidFill>
-              </a:defRPr>
-            </a:pPr>
-            <a:r>
-              <a:t>Memory MCP</a:t>
-            </a:r>
-          </a:p>
-          <a:p>
-            <a:pPr>
-              <a:spcBef>
-                <a:spcPts val="400"/>
-              </a:spcBef>
-              <a:defRPr sz="1100">
-                <a:solidFill>
-                  <a:srgbClr val="E2E8F0"/>
-                </a:solidFill>
-              </a:defRPr>
-            </a:pPr>
-            <a:r>
-              <a:t>Tools: load_state · set_pipeline_status · get_task_queue · log_task_result</a:t>
-            </a:r>
-          </a:p>
-          <a:p>
-            <a:pPr>
-              <a:spcBef>
-                <a:spcPts val="400"/>
-              </a:spcBef>
-              <a:defRPr sz="1100">
-                <a:solidFill>
-                  <a:srgbClr val="E2E8F0"/>
-                </a:solidFill>
-              </a:defRPr>
-            </a:pPr>
-            <a:r>
-              <a:t>Used by: All agents + UI</a:t>
-            </a:r>
-          </a:p>
-        </p:txBody>
-      </p:sp>
-      <p:sp>
-        <p:nvSpPr>
-          <p:cNvPr id="10" name="Rounded Rectangle 9"/>
-          <p:cNvSpPr/>
-          <p:nvPr/>
-        </p:nvSpPr>
-        <p:spPr>
-          <a:xfrm>
-            <a:off x="6126480" y="3657600"/>
-            <a:ext cx="5394960" cy="2148840"/>
-          </a:xfrm>
-          <a:prstGeom prst="roundRect">
-            <a:avLst/>
-          </a:prstGeom>
-          <a:solidFill>
-            <a:srgbClr val="1E1B4B"/>
-          </a:solidFill>
-          <a:ln w="19050">
-            <a:solidFill>
-              <a:srgbClr val="34D399"/>
-            </a:solidFill>
-          </a:ln>
-        </p:spPr>
-        <p:style>
-          <a:lnRef idx="1">
-            <a:schemeClr val="accent1"/>
-          </a:lnRef>
-          <a:fillRef idx="3">
-            <a:schemeClr val="accent1"/>
-          </a:fillRef>
-          <a:effectRef idx="2">
-            <a:schemeClr val="accent1"/>
-          </a:effectRef>
-          <a:fontRef idx="minor">
-            <a:schemeClr val="lt1"/>
-          </a:fontRef>
-        </p:style>
-        <p:txBody>
-          <a:bodyPr rtlCol="0" anchor="ctr"/>
-          <a:lstStyle/>
-          <a:p>
-            <a:pPr algn="ctr"/>
-          </a:p>
-        </p:txBody>
-      </p:sp>
-      <p:sp>
-        <p:nvSpPr>
-          <p:cNvPr id="11" name="TextBox 10"/>
-          <p:cNvSpPr txBox="1"/>
-          <p:nvPr/>
-        </p:nvSpPr>
-        <p:spPr>
-          <a:xfrm>
-            <a:off x="6263640" y="3767328"/>
-            <a:ext cx="5120640" cy="1965960"/>
-          </a:xfrm>
-          <a:prstGeom prst="rect">
-            <a:avLst/>
-          </a:prstGeom>
-          <a:noFill/>
-        </p:spPr>
-        <p:txBody>
-          <a:bodyPr wrap="square">
-            <a:spAutoFit/>
-          </a:bodyPr>
-          <a:lstStyle/>
-          <a:p>
-            <a:pPr>
-              <a:defRPr b="1" sz="1400">
-                <a:solidFill>
-                  <a:srgbClr val="34D399"/>
-                </a:solidFill>
-              </a:defRPr>
-            </a:pPr>
-            <a:r>
-              <a:t>Browser MCP</a:t>
-            </a:r>
-          </a:p>
-          <a:p>
-            <a:pPr>
-              <a:spcBef>
-                <a:spcPts val="400"/>
-              </a:spcBef>
-              <a:defRPr sz="1100">
-                <a:solidFill>
-                  <a:srgbClr val="E2E8F0"/>
-                </a:solidFill>
-              </a:defRPr>
-            </a:pPr>
-            <a:r>
-              <a:t>Tools: run_unit_tests · run_browser_tests · run_sprint_task_tests</a:t>
-            </a:r>
-          </a:p>
-          <a:p>
-            <a:pPr>
-              <a:spcBef>
-                <a:spcPts val="400"/>
-              </a:spcBef>
-              <a:defRPr sz="1100">
-                <a:solidFill>
-                  <a:srgbClr val="E2E8F0"/>
-                </a:solidFill>
-              </a:defRPr>
-            </a:pPr>
-            <a:r>
-              <a:t>Used by: Tester Agent quality gate</a:t>
-            </a:r>
-          </a:p>
-        </p:txBody>
-      </p:sp>
-      <p:sp>
-        <p:nvSpPr>
-          <p:cNvPr id="12" name="TextBox 11"/>
-          <p:cNvSpPr txBox="1"/>
-          <p:nvPr/>
-        </p:nvSpPr>
-        <p:spPr>
-          <a:xfrm>
-            <a:off x="457200" y="5989320"/>
-            <a:ext cx="10972800" cy="411480"/>
-          </a:xfrm>
-          <a:prstGeom prst="rect">
-            <a:avLst/>
-          </a:prstGeom>
-          <a:noFill/>
-        </p:spPr>
-        <p:txBody>
-          <a:bodyPr wrap="none">
-            <a:spAutoFit/>
-          </a:bodyPr>
-          <a:lstStyle/>
-          <a:p>
-            <a:pPr algn="ctr">
-              <a:defRPr sz="1100">
-                <a:solidFill>
-                  <a:srgbClr val="94A3B8"/>
-                </a:solidFill>
-              </a:defRPr>
-            </a:pPr>
-            <a:r>
-              <a:t>MCP decouples agents from integrations — swap Plane/GitHub/test backends without changing UI or watcher logic</a:t>
-            </a:r>
-          </a:p>
-        </p:txBody>
-      </p:sp>
-      <p:sp>
-        <p:nvSpPr>
-          <p:cNvPr id="13" name="TextBox 12"/>
+              <a:t>• Frontend polls /api/agents/status for pipeline progress (10s interval, pauses on Build only)</a:t>
+            </a:r>
+          </a:p>
+        </p:txBody>
+      </p:sp>
+      <p:sp>
+        <p:nvSpPr>
+          <p:cNvPr id="5" name="TextBox 4"/>
           <p:cNvSpPr txBox="1"/>
           <p:nvPr/>
         </p:nvSpPr>
@@ -6055,314 +5551,7 @@
       <p:grpSpPr/>
       <p:sp>
         <p:nvSpPr>
-          <p:cNvPr id="2" name="Rectangle 1"/>
-          <p:cNvSpPr/>
-          <p:nvPr/>
-        </p:nvSpPr>
-        <p:spPr>
-          <a:xfrm>
-            <a:off x="0" y="0"/>
-            <a:ext cx="12188952" cy="73152"/>
-          </a:xfrm>
-          <a:prstGeom prst="rect">
-            <a:avLst/>
-          </a:prstGeom>
-          <a:solidFill>
-            <a:srgbClr val="7C3AED"/>
-          </a:solidFill>
-          <a:ln>
-            <a:noFill/>
-          </a:ln>
-        </p:spPr>
-        <p:style>
-          <a:lnRef idx="1">
-            <a:schemeClr val="accent1"/>
-          </a:lnRef>
-          <a:fillRef idx="3">
-            <a:schemeClr val="accent1"/>
-          </a:fillRef>
-          <a:effectRef idx="2">
-            <a:schemeClr val="accent1"/>
-          </a:effectRef>
-          <a:fontRef idx="minor">
-            <a:schemeClr val="lt1"/>
-          </a:fontRef>
-        </p:style>
-        <p:txBody>
-          <a:bodyPr rtlCol="0" anchor="ctr"/>
-          <a:lstStyle/>
-          <a:p>
-            <a:pPr algn="ctr"/>
-          </a:p>
-        </p:txBody>
-      </p:sp>
-      <p:sp>
-        <p:nvSpPr>
-          <p:cNvPr id="3" name="TextBox 2"/>
-          <p:cNvSpPr txBox="1"/>
-          <p:nvPr/>
-        </p:nvSpPr>
-        <p:spPr>
-          <a:xfrm>
-            <a:off x="548640" y="320040"/>
-            <a:ext cx="10972800" cy="1097280"/>
-          </a:xfrm>
-          <a:prstGeom prst="rect">
-            <a:avLst/>
-          </a:prstGeom>
-          <a:noFill/>
-        </p:spPr>
-        <p:txBody>
-          <a:bodyPr wrap="none">
-            <a:spAutoFit/>
-          </a:bodyPr>
-          <a:lstStyle/>
-          <a:p>
-            <a:pPr>
-              <a:defRPr sz="3600" b="1">
-                <a:solidFill>
-                  <a:srgbClr val="FFFFFF"/>
-                </a:solidFill>
-              </a:defRPr>
-            </a:pPr>
-            <a:r>
-              <a:t>Data Flow — Dashboard to Database</a:t>
-            </a:r>
-          </a:p>
-          <a:p>
-            <a:pPr>
-              <a:spcBef>
-                <a:spcPts val="800"/>
-              </a:spcBef>
-              <a:defRPr sz="1600">
-                <a:solidFill>
-                  <a:srgbClr val="A78BFA"/>
-                </a:solidFill>
-              </a:defRPr>
-            </a:pPr>
-            <a:r>
-              <a:t>Single-warehouse filtering · dual search modes</a:t>
-            </a:r>
-          </a:p>
-        </p:txBody>
-      </p:sp>
-      <p:sp>
-        <p:nvSpPr>
-          <p:cNvPr id="4" name="TextBox 3"/>
-          <p:cNvSpPr txBox="1"/>
-          <p:nvPr/>
-        </p:nvSpPr>
-        <p:spPr>
-          <a:xfrm>
-            <a:off x="640080" y="1371600"/>
-            <a:ext cx="10789920" cy="4754880"/>
-          </a:xfrm>
-          <a:prstGeom prst="rect">
-            <a:avLst/>
-          </a:prstGeom>
-          <a:noFill/>
-        </p:spPr>
-        <p:txBody>
-          <a:bodyPr wrap="square">
-            <a:spAutoFit/>
-          </a:bodyPr>
-          <a:lstStyle/>
-          <a:p>
-            <a:pPr>
-              <a:spcAft>
-                <a:spcPts val="1000"/>
-              </a:spcAft>
-              <a:defRPr sz="1400">
-                <a:solidFill>
-                  <a:srgbClr val="E2E8F0"/>
-                </a:solidFill>
-              </a:defRPr>
-            </a:pPr>
-            <a:r>
-              <a:t>• Global Header Submit → oerdte + target_db + oewhse → /api/charts/* + /api/warehouse/statistics</a:t>
-            </a:r>
-          </a:p>
-          <a:p>
-            <a:pPr>
-              <a:spcBef>
-                <a:spcPts val="600"/>
-              </a:spcBef>
-              <a:spcAft>
-                <a:spcPts val="1000"/>
-              </a:spcAft>
-              <a:defRPr sz="1400">
-                <a:solidFill>
-                  <a:srgbClr val="E2E8F0"/>
-                </a:solidFill>
-              </a:defRPr>
-            </a:pPr>
-            <a:r>
-              <a:t>• AI Copilot Ask → POST /api/analytics/ai-copilot with oerdte='' (all dates, NL intent)</a:t>
-            </a:r>
-          </a:p>
-          <a:p>
-            <a:pPr>
-              <a:spcBef>
-                <a:spcPts val="600"/>
-              </a:spcBef>
-              <a:spcAft>
-                <a:spcPts val="1000"/>
-              </a:spcAft>
-              <a:defRPr sz="1400">
-                <a:solidFill>
-                  <a:srgbClr val="E2E8F0"/>
-                </a:solidFill>
-              </a:defRPr>
-            </a:pPr>
-            <a:r>
-              <a:t>• KPI cards, bar chart, scatter plot, warehouse table refresh from same filter context</a:t>
-            </a:r>
-          </a:p>
-          <a:p>
-            <a:pPr>
-              <a:spcBef>
-                <a:spcPts val="600"/>
-              </a:spcBef>
-              <a:spcAft>
-                <a:spcPts val="1000"/>
-              </a:spcAft>
-              <a:defRPr sz="1400">
-                <a:solidFill>
-                  <a:srgbClr val="E2E8F0"/>
-                </a:solidFill>
-              </a:defRPr>
-            </a:pPr>
-            <a:r>
-              <a:t>• When warehouse selected: charts show ONLY that facility (Task 27 rule)</a:t>
-            </a:r>
-          </a:p>
-          <a:p>
-            <a:pPr>
-              <a:spcBef>
-                <a:spcPts val="600"/>
-              </a:spcBef>
-              <a:spcAft>
-                <a:spcPts val="1000"/>
-              </a:spcAft>
-              <a:defRPr sz="1400">
-                <a:solidFill>
-                  <a:srgbClr val="E2E8F0"/>
-                </a:solidFill>
-              </a:defRPr>
-            </a:pPr>
-            <a:r>
-              <a:t>• Frontend polls /api/agents/status for pipeline progress (10s interval, pauses on Build only)</a:t>
-            </a:r>
-          </a:p>
-        </p:txBody>
-      </p:sp>
-      <p:sp>
-        <p:nvSpPr>
-          <p:cNvPr id="5" name="TextBox 4"/>
-          <p:cNvSpPr txBox="1"/>
-          <p:nvPr/>
-        </p:nvSpPr>
-        <p:spPr>
-          <a:xfrm>
-            <a:off x="457200" y="6446520"/>
-            <a:ext cx="10972800" cy="320040"/>
-          </a:xfrm>
-          <a:prstGeom prst="rect">
-            <a:avLst/>
-          </a:prstGeom>
-          <a:noFill/>
-        </p:spPr>
-        <p:txBody>
-          <a:bodyPr wrap="none">
-            <a:spAutoFit/>
-          </a:bodyPr>
-          <a:lstStyle/>
-          <a:p>
-            <a:pPr algn="ctr">
-              <a:defRPr sz="1000">
-                <a:solidFill>
-                  <a:srgbClr val="94A3B8"/>
-                </a:solidFill>
-              </a:defRPr>
-            </a:pPr>
-            <a:r>
-              <a:t>AgenticOps AI · AI Analytics Dashboard</a:t>
-            </a:r>
-          </a:p>
-        </p:txBody>
-      </p:sp>
-    </p:spTree>
-  </p:cSld>
-  <p:clrMapOvr>
-    <a:masterClrMapping/>
-  </p:clrMapOvr>
-</p:sld>
-</file>
-
-<file path=ppt/slides/slide8.xml><?xml version="1.0" encoding="utf-8"?>
-<p:sld xmlns:a="http://schemas.openxmlformats.org/drawingml/2006/main" xmlns:p="http://schemas.openxmlformats.org/presentationml/2006/main" xmlns:r="http://schemas.openxmlformats.org/officeDocument/2006/relationships">
-  <p:cSld>
-    <p:bg>
-      <p:bgPr>
-        <a:solidFill>
-          <a:srgbClr val="0F172A"/>
-        </a:solidFill>
-        <a:effectLst/>
-      </p:bgPr>
-    </p:bg>
-    <p:spTree>
-      <p:nvGrpSpPr>
-        <p:cNvPr id="1" name=""/>
-        <p:cNvGrpSpPr/>
-        <p:nvPr/>
-      </p:nvGrpSpPr>
-      <p:grpSpPr/>
-      <p:sp>
-        <p:nvSpPr>
-          <p:cNvPr id="2" name="Rectangle 1"/>
-          <p:cNvSpPr/>
-          <p:nvPr/>
-        </p:nvSpPr>
-        <p:spPr>
-          <a:xfrm>
-            <a:off x="0" y="2926080"/>
-            <a:ext cx="12188952" cy="54864"/>
-          </a:xfrm>
-          <a:prstGeom prst="rect">
-            <a:avLst/>
-          </a:prstGeom>
-          <a:solidFill>
-            <a:srgbClr val="7C3AED"/>
-          </a:solidFill>
-          <a:ln>
-            <a:noFill/>
-          </a:ln>
-        </p:spPr>
-        <p:style>
-          <a:lnRef idx="1">
-            <a:schemeClr val="accent1"/>
-          </a:lnRef>
-          <a:fillRef idx="3">
-            <a:schemeClr val="accent1"/>
-          </a:fillRef>
-          <a:effectRef idx="2">
-            <a:schemeClr val="accent1"/>
-          </a:effectRef>
-          <a:fontRef idx="minor">
-            <a:schemeClr val="lt1"/>
-          </a:fontRef>
-        </p:style>
-        <p:txBody>
-          <a:bodyPr rtlCol="0" anchor="ctr"/>
-          <a:lstStyle/>
-          <a:p>
-            <a:pPr algn="ctr"/>
-          </a:p>
-        </p:txBody>
-      </p:sp>
-      <p:sp>
-        <p:nvSpPr>
-          <p:cNvPr id="3" name="TextBox 2"/>
+          <p:cNvPr id="2" name="TextBox 1"/>
           <p:cNvSpPr txBox="1"/>
           <p:nvPr/>
         </p:nvSpPr>
@@ -6457,7 +5646,7 @@
       </p:sp>
       <p:sp>
         <p:nvSpPr>
-          <p:cNvPr id="4" name="TextBox 3"/>
+          <p:cNvPr id="3" name="TextBox 2"/>
           <p:cNvSpPr txBox="1"/>
           <p:nvPr/>
         </p:nvSpPr>

</xml_diff>